<commit_message>
Lecture 2 revision: tightened slide prose, current-campaign figures; sync build_pptx.py
Adds the four new Lecture 2 figures and three Lecture 1 figures the
revised L1 slides already reference but were never committed.

Co-Authored-By: Claude Fable 5 <noreply@anthropic.com>
</commit_message>
<xml_diff>
--- a/me323/Module1_drafts/ME323_Module1_Lecture2.pptx
+++ b/me323/Module1_drafts/ME323_Module1_Lecture2.pptx
@@ -27,6 +27,7 @@
     <p:sldId id="275" r:id="rId26"/>
     <p:sldId id="276" r:id="rId27"/>
     <p:sldId id="277" r:id="rId28"/>
+    <p:sldId id="278" r:id="rId29"/>
   </p:sldIdLst>
   <p:sldSz cx="12191695" cy="6858000" type="screen4x3"/>
   <p:notesSz cx="6858000" cy="9144000"/>
@@ -3339,7 +3340,7 @@
                 </a:solidFill>
                 <a:latin typeface="Calibri"/>
               </a:rPr>
-              <a:t>Watch it learn, one beam at a time</a:t>
+              <a:t>Each test reshapes nearby predictions</a:t>
             </a:r>
           </a:p>
         </p:txBody>
@@ -3390,7 +3391,7 @@
       </p:sp>
       <p:pic>
         <p:nvPicPr>
-          <p:cNvPr id="4" name="Picture 3" descr="gif_gp_learning_beams.gif"/>
+          <p:cNvPr id="4" name="Picture 3" descr="fig_gp_current_campaign_slice.png"/>
           <p:cNvPicPr>
             <a:picLocks noChangeAspect="1"/>
           </p:cNvPicPr>
@@ -3404,8 +3405,8 @@
         </p:blipFill>
         <p:spPr>
           <a:xfrm>
-            <a:off x="2833399" y="1371600"/>
-            <a:ext cx="6524897" cy="4343400"/>
+            <a:off x="2326465" y="1371600"/>
+            <a:ext cx="7538764" cy="4343400"/>
           </a:xfrm>
           <a:prstGeom prst="rect">
             <a:avLst/>
@@ -3446,7 +3447,7 @@
                 </a:solidFill>
                 <a:latin typeface="Calibri"/>
               </a:rPr>
-              <a:t>The band collapses where beams land and stays wide where nothing has been tested.</a:t>
+              <a:t>Current class-campaign data on a thin-web slice: the band narrows near tested beams.</a:t>
             </a:r>
           </a:p>
         </p:txBody>
@@ -3485,7 +3486,7 @@
                 </a:solidFill>
                 <a:latin typeface="Calibri"/>
               </a:rPr>
-              <a:t>Earlier span-200 campaign; rebuilt from the new 44-beam dataset when testing finishes.  (animated in slideshow)</a:t>
+              <a:t>The band stays wide where the model has less support.</a:t>
             </a:r>
           </a:p>
         </p:txBody>
@@ -3761,7 +3762,7 @@
                 </a:solidFill>
                 <a:latin typeface="Calibri"/>
               </a:rPr>
-              <a:t>So is the noise</a:t>
+              <a:t>Noise changes both the fit and its uncertainty</a:t>
             </a:r>
           </a:p>
         </p:txBody>
@@ -3812,7 +3813,7 @@
       </p:sp>
       <p:pic>
         <p:nvPicPr>
-          <p:cNvPr id="4" name="Picture 3" descr="fig_noise_fits.png"/>
+          <p:cNvPr id="4" name="Picture 3" descr="fig_noise_uncertainty_shared_scales.png"/>
           <p:cNvPicPr>
             <a:picLocks noChangeAspect="1"/>
           </p:cNvPicPr>
@@ -3826,8 +3827,8 @@
         </p:blipFill>
         <p:spPr>
           <a:xfrm>
-            <a:off x="792327" y="1371600"/>
-            <a:ext cx="10607040" cy="3383279"/>
+            <a:off x="2295372" y="1371600"/>
+            <a:ext cx="7600950" cy="4343400"/>
           </a:xfrm>
           <a:prstGeom prst="rect">
             <a:avLst/>
@@ -3842,7 +3843,7 @@
         </p:nvSpPr>
         <p:spPr>
           <a:xfrm>
-            <a:off x="822960" y="4828031"/>
+            <a:off x="822960" y="5788152"/>
             <a:ext cx="10607040" cy="548640"/>
           </a:xfrm>
           <a:prstGeom prst="rect">
@@ -3868,7 +3869,7 @@
                 </a:solidFill>
                 <a:latin typeface="Calibri"/>
               </a:rPr>
-              <a:t>We assume 3% as the class working value. Pre-lab 2 refits at 1%, 3%, and 10%.</a:t>
+              <a:t>Pre-lab 2 refits at 1%, 3%, and 10% using shared row-wise color scales.</a:t>
             </a:r>
           </a:p>
         </p:txBody>
@@ -3881,7 +3882,7 @@
         </p:nvSpPr>
         <p:spPr>
           <a:xfrm>
-            <a:off x="822960" y="5285231"/>
+            <a:off x="822960" y="6245352"/>
             <a:ext cx="10607040" cy="365760"/>
           </a:xfrm>
           <a:prstGeom prst="rect">
@@ -3907,7 +3908,7 @@
                 </a:solidFill>
                 <a:latin typeface="Calibri"/>
               </a:rPr>
-              <a:t>The recommendation moves: 1% picks (1.58, 14.88), while 3% and 10% pick (1.00, 13.39). The action is assumption-sensitive.</a:t>
+              <a:t>The 1% fit recommends (1.58, 14.88); the 3% and 10% fits recommend (1.00, 13.39).</a:t>
             </a:r>
           </a:p>
         </p:txBody>
@@ -4055,7 +4056,7 @@
                 </a:solidFill>
                 <a:latin typeface="Calibri"/>
               </a:rPr>
-              <a:t>•  Epistemic: uncertainty about the latent surface because tests are sparse. Informative beams can reduce it.</a:t>
+              <a:t>•  Epistemic: uncertainty about the underlying average trend because tests are sparse. An informative new beam can reduce it.</a:t>
             </a:r>
           </a:p>
           <a:p>
@@ -4071,7 +4072,7 @@
                 </a:solidFill>
                 <a:latin typeface="Calibri"/>
               </a:rPr>
-              <a:t>•  Aleatory: print-to-print and test-to-test scatter at one nominal design. Another location does not remove it.</a:t>
+              <a:t>•  Aleatory: print-to-print and test-to-test scatter at one nominal design. Testing another location does not remove it.</a:t>
             </a:r>
           </a:p>
           <a:p>
@@ -4168,7 +4169,7 @@
                 </a:solidFill>
                 <a:latin typeface="Calibri"/>
               </a:rPr>
-              <a:t>Explore vs exploit</a:t>
+              <a:t>One dial balances performance and uncertainty</a:t>
             </a:r>
           </a:p>
         </p:txBody>
@@ -4299,7 +4300,7 @@
                 </a:solidFill>
                 <a:latin typeface="Calibri"/>
               </a:rPr>
-              <a:t>Exploit: test where the posterior median is highest. Explore: test where epistemic uncertainty is widest. MUI (maximum upper interval) uses latent log space.</a:t>
+              <a:t>a(x): acquisition-function score; mu(x): predicted log(str/w); sigma(x): epistemic uncertainty; psi: how strongly uncertainty affects the choice.</a:t>
             </a:r>
           </a:p>
         </p:txBody>
@@ -4471,7 +4472,7 @@
                 </a:solidFill>
                 <a:latin typeface="Calibri"/>
               </a:rPr>
-              <a:t>Fit, pick the acquisition argmax, test, refit. It probes the thin-web corner once, learns the dip, settles on the peak.</a:t>
+              <a:t>Fit, evaluate the acquisition function, choose the design with the highest score, test, and refit.</a:t>
             </a:r>
           </a:p>
         </p:txBody>
@@ -4575,7 +4576,7 @@
                 </a:solidFill>
                 <a:latin typeface="Calibri"/>
               </a:rPr>
-              <a:t>Expected Improvement, the other dial</a:t>
+              <a:t>EI weighs the chance and size of a win</a:t>
             </a:r>
           </a:p>
         </p:txBody>
@@ -4624,16 +4625,40 @@
           </a:p>
         </p:txBody>
       </p:sp>
-      <p:sp>
-        <p:nvSpPr>
-          <p:cNvPr id="4" name="TextBox 3"/>
+      <p:pic>
+        <p:nvPicPr>
+          <p:cNvPr id="4" name="Picture 3" descr="fig_mui_ei_current.png"/>
+          <p:cNvPicPr>
+            <a:picLocks noChangeAspect="1"/>
+          </p:cNvPicPr>
+          <p:nvPr/>
+        </p:nvPicPr>
+        <p:blipFill>
+          <a:blip r:embed="rId2"/>
+          <a:stretch>
+            <a:fillRect/>
+          </a:stretch>
+        </p:blipFill>
+        <p:spPr>
+          <a:xfrm>
+            <a:off x="792327" y="1371600"/>
+            <a:ext cx="10607040" cy="4239809"/>
+          </a:xfrm>
+          <a:prstGeom prst="rect">
+            <a:avLst/>
+          </a:prstGeom>
+        </p:spPr>
+      </p:pic>
+      <p:sp>
+        <p:nvSpPr>
+          <p:cNvPr id="5" name="TextBox 4"/>
           <p:cNvSpPr txBox="1"/>
           <p:nvPr/>
         </p:nvSpPr>
         <p:spPr>
           <a:xfrm>
-            <a:off x="868680" y="1554480"/>
-            <a:ext cx="10424160" cy="4754880"/>
+            <a:off x="822960" y="5684561"/>
+            <a:ext cx="10607040" cy="548640"/>
           </a:xfrm>
           <a:prstGeom prst="rect">
             <a:avLst/>
@@ -4646,83 +4671,58 @@
           </a:bodyPr>
           <a:lstStyle/>
           <a:p>
-            <a:pPr algn="l">
-              <a:spcAft>
-                <a:spcPts val="1200"/>
-              </a:spcAft>
-            </a:pPr>
-            <a:r>
-              <a:rPr sz="2100" b="0">
+            <a:pPr algn="ctr">
+              <a:spcAft>
+                <a:spcPts val="600"/>
+              </a:spcAft>
+            </a:pPr>
+            <a:r>
+              <a:rPr sz="1500" b="0">
                 <a:solidFill>
                   <a:srgbClr val="0B0B0B"/>
                 </a:solidFill>
                 <a:latin typeface="Calibri"/>
               </a:rPr>
-              <a:t>EI asks: by how much would a new test beat the best beam so far, on average?</a:t>
-            </a:r>
-          </a:p>
-          <a:p>
-            <a:pPr algn="l" lvl="1">
-              <a:spcAft>
-                <a:spcPts val="1200"/>
-              </a:spcAft>
-            </a:pPr>
-            <a:r>
-              <a:rPr sz="1900" b="0">
-                <a:solidFill>
-                  <a:srgbClr val="0B0B0B"/>
-                </a:solidFill>
-                <a:latin typeface="Calibri"/>
-              </a:rPr>
-              <a:t>•  accounts for both latent mean mu and epistemic uncertainty sigma, like MUI,</a:t>
-            </a:r>
-          </a:p>
-          <a:p>
-            <a:pPr algn="l" lvl="1">
-              <a:spcAft>
-                <a:spcPts val="1200"/>
-              </a:spcAft>
-            </a:pPr>
-            <a:r>
-              <a:rPr sz="1900" b="0">
-                <a:solidFill>
-                  <a:srgbClr val="0B0B0B"/>
-                </a:solidFill>
-                <a:latin typeface="Calibri"/>
-              </a:rPr>
-              <a:t>•  but weighs improvement, so it stops caring about regions that cannot win,</a:t>
-            </a:r>
-          </a:p>
-          <a:p>
-            <a:pPr algn="l" lvl="1">
-              <a:spcAft>
-                <a:spcPts val="1200"/>
-              </a:spcAft>
-            </a:pPr>
-            <a:r>
-              <a:rPr sz="1900" b="0">
-                <a:solidFill>
-                  <a:srgbClr val="0B0B0B"/>
-                </a:solidFill>
-                <a:latin typeface="Calibri"/>
-              </a:rPr>
-              <a:t>•  and it has its own dial, xi: an improvement threshold. xi = 0 lets the probabilities trade on their own; larger xi counts only wins that clear the incumbent by that margin, pushing exploration.</a:t>
-            </a:r>
-          </a:p>
-          <a:p>
-            <a:pPr algn="l">
-              <a:spcAft>
-                <a:spcPts val="1200"/>
-              </a:spcAft>
-            </a:pPr>
-            <a:r>
-              <a:rPr sz="2100" b="0">
-                <a:solidFill>
-                  <a:srgbClr val="0B0B0B"/>
-                </a:solidFill>
-                <a:latin typeface="Calibri"/>
-              </a:rPr>
-              <a:t>MUI and EI can point at different next beams. The choice encodes your appetite for risk; Pre-lab 2 has you code both.</a:t>
+              <a:t>EI asks how much a new test would beat the best tested beam so far, on average.</a:t>
+            </a:r>
+          </a:p>
+        </p:txBody>
+      </p:sp>
+      <p:sp>
+        <p:nvSpPr>
+          <p:cNvPr id="6" name="TextBox 5"/>
+          <p:cNvSpPr txBox="1"/>
+          <p:nvPr/>
+        </p:nvSpPr>
+        <p:spPr>
+          <a:xfrm>
+            <a:off x="822960" y="6141761"/>
+            <a:ext cx="10607040" cy="365760"/>
+          </a:xfrm>
+          <a:prstGeom prst="rect">
+            <a:avLst/>
+          </a:prstGeom>
+          <a:noFill/>
+        </p:spPr>
+        <p:txBody>
+          <a:bodyPr wrap="square" anchor="t">
+            <a:spAutoFit/>
+          </a:bodyPr>
+          <a:lstStyle/>
+          <a:p>
+            <a:pPr algn="ctr">
+              <a:spcAft>
+                <a:spcPts val="600"/>
+              </a:spcAft>
+            </a:pPr>
+            <a:r>
+              <a:rPr sz="1150" b="0">
+                <a:solidFill>
+                  <a:srgbClr val="52514E"/>
+                </a:solidFill>
+                <a:latin typeface="Calibri"/>
+              </a:rPr>
+              <a:t>Increasing xi often favors less-certain regions, but does not guarantee a more exploratory recommendation.</a:t>
             </a:r>
           </a:p>
         </p:txBody>
@@ -4870,7 +4870,7 @@
                 </a:solidFill>
                 <a:latin typeface="Calibri"/>
               </a:rPr>
-              <a:t>Each print-and-test costs a machine slot, a test engineer hour, and days of queue. The class gets two ground-truth queries — answered by the frozen staff model, cheap because the prior campaign already paid for that information — and each group gets one real print.</a:t>
+              <a:t>Each print-and-test costs a machine slot, a test engineer hour, and days of queue. The class gets two pieces of ground-truth data from earlier tests through the frozen staff model, and each group gets one real print.</a:t>
             </a:r>
           </a:p>
           <a:p>
@@ -5018,7 +5018,7 @@
       </p:sp>
       <p:pic>
         <p:nvPicPr>
-          <p:cNvPr id="4" name="Picture 3" descr="gif_pigp_vs_gp.gif"/>
+          <p:cNvPr id="4" name="Picture 3" descr="fig_decision_map_4panel.png"/>
           <p:cNvPicPr>
             <a:picLocks noChangeAspect="1"/>
           </p:cNvPicPr>
@@ -5032,8 +5032,8 @@
         </p:blipFill>
         <p:spPr>
           <a:xfrm>
-            <a:off x="2593105" y="1371600"/>
-            <a:ext cx="7005483" cy="4343400"/>
+            <a:off x="3086211" y="1371600"/>
+            <a:ext cx="6019271" cy="4343400"/>
           </a:xfrm>
           <a:prstGeom prst="rect">
             <a:avLst/>
@@ -5074,7 +5074,7 @@
                 </a:solidFill>
                 <a:latin typeface="Calibri"/>
               </a:rPr>
-              <a:t>Plain GP sees only (b, H_web). Submission 1 lane C also sees log(P_phys) and P_LTB/P_bend from the calibrated three-branch capacity.</a:t>
+              <a:t>A vanilla GP sees geometry only. A physics-informed GP can also receive signals from the calibrated capacity equations.</a:t>
             </a:r>
           </a:p>
         </p:txBody>
@@ -5113,7 +5113,7 @@
                 </a:solidFill>
                 <a:latin typeface="Calibri"/>
               </a:rPr>
-              <a:t>Features sharpen the fit where their physics is useful; the separation branch carries one calibrated tau_i for an interface strength that scatters between sessions.  (animated in slideshow)</a:t>
+              <a:t>Submission 1 compares both approaches rather than assuming either one must win.</a:t>
             </a:r>
           </a:p>
         </p:txBody>
@@ -5178,7 +5178,7 @@
                 </a:solidFill>
                 <a:latin typeface="Calibri"/>
               </a:rPr>
-              <a:t>Two decisions are yours; the rest are stress tests</a:t>
+              <a:t>Decide first; run sensitivity checks afterward</a:t>
             </a:r>
           </a:p>
         </p:txBody>
@@ -5277,7 +5277,7 @@
                 </a:solidFill>
                 <a:latin typeface="Calibri"/>
               </a:rPr>
-              <a:t>•  You own two decisions: the lane — how physics and data combine into one model — and the risk posture — how hard to chase predicted performance versus uncertainty.</a:t>
+              <a:t>•  Students decide: how physics enters the model and the risk posture — how predicted performance and uncertainty affect the choice.</a:t>
             </a:r>
           </a:p>
           <a:p>
@@ -5293,7 +5293,7 @@
                 </a:solidFill>
                 <a:latin typeface="Calibri"/>
               </a:rPr>
-              <a:t>•  The rest — kernel, noise, target scale — are stress tests. After you pick coordinates, swap the kernel and refit at 1% / 3% / 10% noise, and see whether your pick survives.</a:t>
+              <a:t>•  Students check afterward: kernel, noise, and target-scale sensitivity.</a:t>
             </a:r>
           </a:p>
           <a:p>
@@ -5309,7 +5309,7 @@
                 </a:solidFill>
                 <a:latin typeface="Calibri"/>
               </a:rPr>
-              <a:t>The strong conclusion is not "we chose RBF and 3%." It is: "our exact optimum moves under reasonable assumptions, but every defensible model points at this neighborhood" — or, just as strong: "the recommendation is unstable, so we bought information instead of chasing the current maximum."</a:t>
+              <a:t>If reasonable assumptions move the recommendation, report that instability. If they point to the same neighborhood, report local robustness. An unstable result can justify using a test to reduce uncertainty.</a:t>
             </a:r>
           </a:p>
         </p:txBody>
@@ -5374,7 +5374,7 @@
                 </a:solidFill>
                 <a:latin typeface="Calibri"/>
               </a:rPr>
-              <a:t>Where Pre-lab 1 left you</a:t>
+              <a:t>The equations overpredicted a strong beam</a:t>
             </a:r>
           </a:p>
         </p:txBody>
@@ -5457,7 +5457,7 @@
                 </a:solidFill>
                 <a:latin typeface="Calibri"/>
               </a:rPr>
-              <a:t>•  You coded three capacity branches — flexural yield, junction shear-flow separation, LTB — calibrated (sigma_y, k, tau_i), and took the minimum: one capacity number per design.</a:t>
+              <a:t>•  The three calibrated capacity equations selected b = 1.10 mm, H_web = 13.25 mm and predicted 48.7 N/g.</a:t>
             </a:r>
           </a:p>
           <a:p>
@@ -5473,7 +5473,7 @@
                 </a:solidFill>
                 <a:latin typeface="Calibri"/>
               </a:rPr>
-              <a:t>•  The parity plot showed where that number holds and where it misses.</a:t>
+              <a:t>•  Ground-truth data from earlier tests gave 475.7 N = 37.48 N/g, about 23% below the equation prediction.</a:t>
             </a:r>
           </a:p>
           <a:p>
@@ -5489,7 +5489,7 @@
                 </a:solidFill>
                 <a:latin typeface="Calibri"/>
               </a:rPr>
-              <a:t>•  Your optimizer picked b = 1.10, H_web = 13.25 mm: predicted 48.7 N/g. Staff queried the ground truth model — a frozen model fit to a prior campaign of real bend tests, standing in for the testing machine — and it returned 475.7 N = 37.48 N/g on the estimated-mass basis. There all three mode capacities tie within ~1%, so the 'LTB' proxy is a knife-edge call.</a:t>
+              <a:t>•  All three modeled capacities tie within about 1% there, so the design sits on a mode boundary.</a:t>
             </a:r>
           </a:p>
           <a:p>
@@ -5505,7 +5505,7 @@
                 </a:solidFill>
                 <a:latin typeface="Calibri"/>
               </a:rPr>
-              <a:t>The physics gave you a point estimate sitting on a mode boundary, the region where you trust it least. Today's tool adds what is missing: a statement of confidence.</a:t>
+              <a:t>The equations found a strong beam, but overpredicted its performance. Today's tool adds a statement of confidence to the point estimate.</a:t>
             </a:r>
           </a:p>
         </p:txBody>
@@ -5570,7 +5570,7 @@
                 </a:solidFill>
                 <a:latin typeface="Calibri"/>
               </a:rPr>
-              <a:t>The decision map: put both models on the same axes</a:t>
+              <a:t>First compare what physics and the GP predict</a:t>
             </a:r>
           </a:p>
         </p:txBody>
@@ -5677,7 +5677,7 @@
                 </a:solidFill>
                 <a:latin typeface="Calibri"/>
               </a:rPr>
-              <a:t>Calibrated physics (with mode boundaries), GP posterior median, their disagreement, and epistemic sigma — tested beams on every panel. Submission 1 builds this with your knobs.</a:t>
+              <a:t>The top row compares calibrated physics and the GP posterior median on the same design axes.</a:t>
             </a:r>
           </a:p>
         </p:txBody>
@@ -5742,7 +5742,7 @@
                 </a:solidFill>
                 <a:latin typeface="Calibri"/>
               </a:rPr>
-              <a:t>The activity from here</a:t>
+              <a:t>Then inspect disagreement and epistemic uncertainty</a:t>
             </a:r>
           </a:p>
         </p:txBody>
@@ -5791,16 +5791,40 @@
           </a:p>
         </p:txBody>
       </p:sp>
-      <p:sp>
-        <p:nvSpPr>
-          <p:cNvPr id="4" name="TextBox 3"/>
+      <p:pic>
+        <p:nvPicPr>
+          <p:cNvPr id="4" name="Picture 3" descr="fig_decision_map_4panel.png"/>
+          <p:cNvPicPr>
+            <a:picLocks noChangeAspect="1"/>
+          </p:cNvPicPr>
+          <p:nvPr/>
+        </p:nvPicPr>
+        <p:blipFill>
+          <a:blip r:embed="rId2"/>
+          <a:stretch>
+            <a:fillRect/>
+          </a:stretch>
+        </p:blipFill>
+        <p:spPr>
+          <a:xfrm>
+            <a:off x="3244613" y="1371600"/>
+            <a:ext cx="5702467" cy="4114800"/>
+          </a:xfrm>
+          <a:prstGeom prst="rect">
+            <a:avLst/>
+          </a:prstGeom>
+        </p:spPr>
+      </p:pic>
+      <p:sp>
+        <p:nvSpPr>
+          <p:cNvPr id="5" name="TextBox 4"/>
           <p:cNvSpPr txBox="1"/>
           <p:nvPr/>
         </p:nvSpPr>
         <p:spPr>
           <a:xfrm>
-            <a:off x="868680" y="1554480"/>
-            <a:ext cx="10424160" cy="4754880"/>
+            <a:off x="822960" y="5559552"/>
+            <a:ext cx="10607040" cy="548640"/>
           </a:xfrm>
           <a:prstGeom prst="rect">
             <a:avLst/>
@@ -5813,67 +5837,19 @@
           </a:bodyPr>
           <a:lstStyle/>
           <a:p>
-            <a:pPr algn="l" lvl="1">
-              <a:spcAft>
-                <a:spcPts val="1200"/>
-              </a:spcAft>
-            </a:pPr>
-            <a:r>
-              <a:rPr sz="1900" b="0">
+            <a:pPr algn="ctr">
+              <a:spcAft>
+                <a:spcPts val="600"/>
+              </a:spcAft>
+            </a:pPr>
+            <a:r>
+              <a:rPr sz="1500" b="0">
                 <a:solidFill>
                   <a:srgbClr val="0B0B0B"/>
                 </a:solidFill>
                 <a:latin typeface="Calibri"/>
               </a:rPr>
-              <a:t>•  Pre-lab 2: fit the GP, write MUI (and EI), work the noise assumption, find the GP-recommended beam.</a:t>
-            </a:r>
-          </a:p>
-          <a:p>
-            <a:pPr algn="l" lvl="1">
-              <a:spcAft>
-                <a:spcPts val="1200"/>
-              </a:spcAft>
-            </a:pPr>
-            <a:r>
-              <a:rPr sz="1900" b="0">
-                <a:solidFill>
-                  <a:srgbClr val="0B0B0B"/>
-                </a:solidFill>
-                <a:latin typeface="Calibri"/>
-              </a:rPr>
-              <a:t>•  Two queries: the class equation design and the class GP design go to the ground truth model — the same two beams for everyone. Only two.</a:t>
-            </a:r>
-          </a:p>
-          <a:p>
-            <a:pPr algn="l" lvl="1">
-              <a:spcAft>
-                <a:spcPts val="1200"/>
-              </a:spcAft>
-            </a:pPr>
-            <a:r>
-              <a:rPr sz="1900" b="0">
-                <a:solidFill>
-                  <a:srgbClr val="0B0B0B"/>
-                </a:solidFill>
-                <a:latin typeface="Calibri"/>
-              </a:rPr>
-              <a:t>•  Submission 1: combine physics, GP, and the two new points; pick the beam you will print; defend it in the memo.</a:t>
-            </a:r>
-          </a:p>
-          <a:p>
-            <a:pPr algn="l" lvl="1">
-              <a:spcAft>
-                <a:spcPts val="1200"/>
-              </a:spcAft>
-            </a:pPr>
-            <a:r>
-              <a:rPr sz="1900" b="0">
-                <a:solidFill>
-                  <a:srgbClr val="0B0B0B"/>
-                </a:solidFill>
-                <a:latin typeface="Calibri"/>
-              </a:rPr>
-              <a:t>•  Print, test, reflect, redesign: Submission 2 folds your own test result back into the model and asks what it changes.</a:t>
+              <a:t>The bottom row shows where the models disagree and where epistemic uncertainty remains large.</a:t>
             </a:r>
           </a:p>
         </p:txBody>
@@ -5938,7 +5914,7 @@
                 </a:solidFill>
                 <a:latin typeface="Calibri"/>
               </a:rPr>
-              <a:t>Before next time: Pre-lab 2</a:t>
+              <a:t>The activity from here</a:t>
             </a:r>
           </a:p>
         </p:txBody>
@@ -6009,8 +5985,204 @@
           </a:bodyPr>
           <a:lstStyle/>
           <a:p>
+            <a:pPr algn="l" lvl="1">
+              <a:spcAft>
+                <a:spcPts val="1200"/>
+              </a:spcAft>
+            </a:pPr>
+            <a:r>
+              <a:rPr sz="1900" b="0">
+                <a:solidFill>
+                  <a:srgbClr val="0B0B0B"/>
+                </a:solidFill>
+                <a:latin typeface="Calibri"/>
+              </a:rPr>
+              <a:t>•  Pre-lab 2: fit the GP, write MUI (and EI), work the noise assumption, find the GP-recommended beam.</a:t>
+            </a:r>
+          </a:p>
+          <a:p>
+            <a:pPr algn="l" lvl="1">
+              <a:spcAft>
+                <a:spcPts val="1200"/>
+              </a:spcAft>
+            </a:pPr>
+            <a:r>
+              <a:rPr sz="1900" b="0">
+                <a:solidFill>
+                  <a:srgbClr val="0B0B0B"/>
+                </a:solidFill>
+                <a:latin typeface="Calibri"/>
+              </a:rPr>
+              <a:t>•  Two class results: add ground-truth data from earlier tests for the equation design and the GP design — the same two beams for everyone.</a:t>
+            </a:r>
+          </a:p>
+          <a:p>
+            <a:pPr algn="l" lvl="1">
+              <a:spcAft>
+                <a:spcPts val="1200"/>
+              </a:spcAft>
+            </a:pPr>
+            <a:r>
+              <a:rPr sz="1900" b="0">
+                <a:solidFill>
+                  <a:srgbClr val="0B0B0B"/>
+                </a:solidFill>
+                <a:latin typeface="Calibri"/>
+              </a:rPr>
+              <a:t>•  Submission 1: combine physics, GP, and the two new points; pick the beam you will print; defend it in the memo.</a:t>
+            </a:r>
+          </a:p>
+          <a:p>
+            <a:pPr algn="l" lvl="1">
+              <a:spcAft>
+                <a:spcPts val="1200"/>
+              </a:spcAft>
+            </a:pPr>
+            <a:r>
+              <a:rPr sz="1900" b="0">
+                <a:solidFill>
+                  <a:srgbClr val="0B0B0B"/>
+                </a:solidFill>
+                <a:latin typeface="Calibri"/>
+              </a:rPr>
+              <a:t>•  Print, test, reflect, redesign: Submission 2 folds your own test result back into the model and asks what it changes.</a:t>
+            </a:r>
+          </a:p>
+        </p:txBody>
+      </p:sp>
+    </p:spTree>
+  </p:cSld>
+  <p:clrMapOvr>
+    <a:masterClrMapping/>
+  </p:clrMapOvr>
+</p:sld>
+</file>
+
+<file path=ppt/slides/slide23.xml><?xml version="1.0" encoding="utf-8"?>
+<p:sld xmlns:a="http://schemas.openxmlformats.org/drawingml/2006/main" xmlns:p="http://schemas.openxmlformats.org/presentationml/2006/main" xmlns:r="http://schemas.openxmlformats.org/officeDocument/2006/relationships">
+  <p:cSld>
+    <p:bg>
+      <p:bgPr>
+        <a:solidFill>
+          <a:srgbClr val="FCFCFB"/>
+        </a:solidFill>
+        <a:effectLst/>
+      </p:bgPr>
+    </p:bg>
+    <p:spTree>
+      <p:nvGrpSpPr>
+        <p:cNvPr id="1" name=""/>
+        <p:cNvGrpSpPr/>
+        <p:nvPr/>
+      </p:nvGrpSpPr>
+      <p:grpSpPr/>
+      <p:sp>
+        <p:nvSpPr>
+          <p:cNvPr id="2" name="TextBox 1"/>
+          <p:cNvSpPr txBox="1"/>
+          <p:nvPr/>
+        </p:nvSpPr>
+        <p:spPr>
+          <a:xfrm>
+            <a:off x="822960" y="384048"/>
+            <a:ext cx="10607040" cy="822960"/>
+          </a:xfrm>
+          <a:prstGeom prst="rect">
+            <a:avLst/>
+          </a:prstGeom>
+          <a:noFill/>
+        </p:spPr>
+        <p:txBody>
+          <a:bodyPr wrap="square" anchor="t">
+            <a:spAutoFit/>
+          </a:bodyPr>
+          <a:lstStyle/>
+          <a:p>
             <a:pPr algn="l">
               <a:spcAft>
+                <a:spcPts val="600"/>
+              </a:spcAft>
+            </a:pPr>
+            <a:r>
+              <a:rPr sz="3000" b="1">
+                <a:solidFill>
+                  <a:srgbClr val="0B0B0B"/>
+                </a:solidFill>
+                <a:latin typeface="Calibri"/>
+              </a:rPr>
+              <a:t>Before next time: Pre-lab 2</a:t>
+            </a:r>
+          </a:p>
+        </p:txBody>
+      </p:sp>
+      <p:sp>
+        <p:nvSpPr>
+          <p:cNvPr id="3" name="Rectangle 2"/>
+          <p:cNvSpPr/>
+          <p:nvPr/>
+        </p:nvSpPr>
+        <p:spPr>
+          <a:xfrm>
+            <a:off x="822960" y="1170432"/>
+            <a:ext cx="1463040" cy="54864"/>
+          </a:xfrm>
+          <a:prstGeom prst="rect">
+            <a:avLst/>
+          </a:prstGeom>
+          <a:solidFill>
+            <a:srgbClr val="2A78D6"/>
+          </a:solidFill>
+          <a:ln>
+            <a:noFill/>
+          </a:ln>
+          <a:effectLst/>
+        </p:spPr>
+        <p:style>
+          <a:lnRef idx="1">
+            <a:schemeClr val="accent1"/>
+          </a:lnRef>
+          <a:fillRef idx="3">
+            <a:schemeClr val="accent1"/>
+          </a:fillRef>
+          <a:effectRef idx="2">
+            <a:schemeClr val="accent1"/>
+          </a:effectRef>
+          <a:fontRef idx="minor">
+            <a:schemeClr val="lt1"/>
+          </a:fontRef>
+        </p:style>
+        <p:txBody>
+          <a:bodyPr rtlCol="0" anchor="ctr"/>
+          <a:lstStyle/>
+          <a:p>
+            <a:pPr algn="ctr"/>
+          </a:p>
+        </p:txBody>
+      </p:sp>
+      <p:sp>
+        <p:nvSpPr>
+          <p:cNvPr id="4" name="TextBox 3"/>
+          <p:cNvSpPr txBox="1"/>
+          <p:nvPr/>
+        </p:nvSpPr>
+        <p:spPr>
+          <a:xfrm>
+            <a:off x="868680" y="1554480"/>
+            <a:ext cx="10424160" cy="4754880"/>
+          </a:xfrm>
+          <a:prstGeom prst="rect">
+            <a:avLst/>
+          </a:prstGeom>
+          <a:noFill/>
+        </p:spPr>
+        <p:txBody>
+          <a:bodyPr wrap="square" anchor="t">
+            <a:spAutoFit/>
+          </a:bodyPr>
+          <a:lstStyle/>
+          <a:p>
+            <a:pPr algn="l">
+              <a:spcAft>
                 <a:spcPts val="1200"/>
               </a:spcAft>
             </a:pPr>
@@ -6117,7 +6289,7 @@
                 </a:solidFill>
                 <a:latin typeface="Calibri"/>
               </a:rPr>
-              <a:t>That beam is the class's second ground-truth query. Bring your rationale, not just the number.</a:t>
+              <a:t>That beam is the class's second ground-truth data point from earlier tests. Bring your rationale, not just the number.</a:t>
             </a:r>
           </a:p>
         </p:txBody>
@@ -6533,7 +6705,7 @@
                 </a:solidFill>
                 <a:latin typeface="Calibri"/>
               </a:rPr>
-              <a:t>Carry a distribution over the unknown strength surface, not a single guess.</a:t>
+              <a:t>Prior: belief before the test. Likelihood: compatibility with the result. Posterior: belief after the test.</a:t>
             </a:r>
           </a:p>
           <a:p>
@@ -6549,7 +6721,7 @@
                 </a:solidFill>
                 <a:latin typeface="Calibri"/>
               </a:rPr>
-              <a:t>Every slide that follows is this line, applied to beams.</a:t>
+              <a:t>Carry a distribution over unknown beam strength, not a single guess.</a:t>
             </a:r>
           </a:p>
         </p:txBody>
@@ -6665,7 +6837,7 @@
       </p:sp>
       <p:pic>
         <p:nvPicPr>
-          <p:cNvPr id="4" name="Picture 3" descr="fig_gauss_strength.png"/>
+          <p:cNvPr id="4" name="Picture 3" descr="fig_gauss_strength_repeats.png"/>
           <p:cNvPicPr>
             <a:picLocks noChangeAspect="1"/>
           </p:cNvPicPr>
@@ -6679,8 +6851,8 @@
         </p:blipFill>
         <p:spPr>
           <a:xfrm>
-            <a:off x="2295372" y="1371600"/>
-            <a:ext cx="7600950" cy="4343400"/>
+            <a:off x="2089632" y="1371600"/>
+            <a:ext cx="8012430" cy="4343400"/>
           </a:xfrm>
           <a:prstGeom prst="rect">
             <a:avLst/>
@@ -6721,7 +6893,7 @@
                 </a:solidFill>
                 <a:latin typeface="Calibri"/>
               </a:rPr>
-              <a:t>Exactly ME 239's "fitting Normals to data" (lecture 12) — mean, variance, st.norm — done on strength. Pre-lab 2's warm-up replays it on these four beams.</a:t>
+              <a:t>Four repeat tests at one design give mean 558.2 N and fitted scatter 7.6 N, about 1.4%.</a:t>
             </a:r>
           </a:p>
         </p:txBody>
@@ -6760,7 +6932,7 @@
                 </a:solidFill>
                 <a:latin typeface="Calibri"/>
               </a:rPr>
-              <a:t>Where does 3% come from? Four repeat prints at (1.3, 12.8) spanned 548.6-566.1 N; pooled over all repeats the scatter runs ~4.4% with session/printer structure. 3% is the stated class working value.</a:t>
+              <a:t>Pooled campaign repeats give about 4.4% with session/printer structure. The class uses 3% as a working assumption and checks its effect.</a:t>
             </a:r>
           </a:p>
         </p:txBody>
@@ -7247,7 +7419,7 @@
                 </a:solidFill>
                 <a:latin typeface="Calibri"/>
               </a:rPr>
-              <a:t>A function is a long Gaussian vector</a:t>
+              <a:t>A GP links predictions across many designs</a:t>
             </a:r>
           </a:p>
         </p:txBody>
@@ -7354,7 +7526,7 @@
                 </a:solidFill>
                 <a:latin typeface="Calibri"/>
               </a:rPr>
-              <a:t>Strength at 2 designs is a 2D Gaussian; at 120 designs, a 120-D Gaussian. Connect the dots and it is a function.</a:t>
+              <a:t>The same joint-Gaussian update can cover 2 designs or 120.</a:t>
             </a:r>
           </a:p>
         </p:txBody>
@@ -7393,7 +7565,7 @@
                 </a:solidFill>
                 <a:latin typeface="Calibri"/>
               </a:rPr>
-              <a:t>A kernel fills in the covariances: nearby beams correlate, distant ones do not.  (animated in slideshow)</a:t>
+              <a:t>A kernel makes a test influence nearby designs more than distant ones.  (animated in slideshow)</a:t>
             </a:r>
           </a:p>
         </p:txBody>

</xml_diff>